<commit_message>
Strip remaining engineer jargon from the deck
"unvalidated model", "downstream code", "microcontroller", "pipeline",
and "architecture" all read fine to an engineer and as jargon to
everyone else. Replaced with plain language on every slide that had
it -- same facts, same numbers, no vocabulary a non-technical judge
has to translate mid-pitch.
</commit_message>
<xml_diff>
--- a/presentation/Pulso_Pitch_Deck.pptx
+++ b/presentation/Pulso_Pitch_Deck.pptx
@@ -1039,7 +1039,7 @@
           <a:p>
             <a:r>
               <a:rPr lang="en-US" dirty="0"/>
-              <a:t>Say 'same brain' and gesture at all four -- don't read file names or explain the pipeline, the point is that it's one system, not four.</a:t>
+              <a:t>Say 'same brain' and gesture at all four -- the point is that it's one system, not four. Don't explain how it works under the hood.</a:t>
             </a:r>
             <a:endParaRPr lang="en-US" dirty="0"/>
           </a:p>
@@ -2714,7 +2714,7 @@
                 <a:ea typeface="Cambria" pitchFamily="34" charset="-122"/>
                 <a:cs typeface="Cambria" pitchFamily="34" charset="-120"/>
               </a:rPr>
-              <a:t>A wrong “you have X” from an unvalidated model is dangerous.</a:t>
+              <a:t>A wrong “you have X” from AI that's never been checked is dangerous.</a:t>
             </a:r>
             <a:endParaRPr lang="en-US" sz="2400" dirty="0"/>
           </a:p>
@@ -3683,7 +3683,7 @@
                 <a:ea typeface="Cambria" pitchFamily="34" charset="-122"/>
                 <a:cs typeface="Cambria" pitchFamily="34" charset="-120"/>
               </a:rPr>
-              <a:t>Two real bugs caught before they shipped. A hardware swap that touched zero lines of downstream code.</a:t>
+              <a:t>Two real bugs caught before they ever reached a user. We swapped in new hardware and nothing else broke.</a:t>
             </a:r>
             <a:endParaRPr lang="en-US" sz="1700" dirty="0"/>
           </a:p>
@@ -3957,7 +3957,7 @@
                 <a:ea typeface="Calibri" pitchFamily="34" charset="-122"/>
                 <a:cs typeface="Calibri" pitchFamily="34" charset="-120"/>
               </a:rPr>
-              <a:t>A microphone module on an off-the-shelf microcontroller. Whether the audio comes from that board, a phone, a laptop mic, or a recorded file — it hits the exact same pipeline, unmodified.</a:t>
+              <a:t>A cheap microphone chip picks up the sound. Swap in a phone, a laptop, or a recorded file instead — everything else stays exactly the same.</a:t>
             </a:r>
             <a:endParaRPr lang="en-US" sz="1500" dirty="0"/>
           </a:p>
@@ -5856,7 +5856,7 @@
                 <a:ea typeface="Courier New" pitchFamily="34" charset="-122"/>
                 <a:cs typeface="Courier New" pitchFamily="34" charset="-120"/>
               </a:rPr>
-              <a:t>Validate against a labeled clinical dataset</a:t>
+              <a:t>Test it against real, labeled medical recordings</a:t>
             </a:r>
             <a:endParaRPr lang="en-US" sz="1500" dirty="0"/>
           </a:p>
@@ -5895,7 +5895,7 @@
                 <a:ea typeface="Calibri" pitchFamily="34" charset="-122"/>
                 <a:cs typeface="Calibri" pitchFamily="34" charset="-120"/>
               </a:rPr>
-              <a:t>Architecture already accepts it — blocked this weekend only by network access.</a:t>
+              <a:t>We're ready for this — we just couldn't reach the data this weekend.</a:t>
             </a:r>
             <a:endParaRPr lang="en-US" sz="1300" dirty="0"/>
           </a:p>
@@ -5973,7 +5973,7 @@
                 <a:ea typeface="Courier New" pitchFamily="34" charset="-122"/>
                 <a:cs typeface="Courier New" pitchFamily="34" charset="-120"/>
               </a:rPr>
-              <a:t>Field-test the sensor against real skin contact</a:t>
+              <a:t>Test the microphone against real skin contact</a:t>
             </a:r>
             <a:endParaRPr lang="en-US" sz="1500" dirty="0"/>
           </a:p>

</xml_diff>

<commit_message>
Sync both pitch decks with the two-channel pricing model and rate label fix
The English deck's Business Model and Pricing slides already had the
institutional (B2B2G) vs direct-to-clinic (B2B) restructuring; the
Azerbaijani deck was still on the old single-channel version. Translated
and applied the same changes so both decks match the live pricing page.

Also relabeled "Heart rate"/"Ürək tezliyi" to "Rate"/"Tezlik" on the live
demo slide's readout table in both decks, matching the same fix already
made to the live app and landing page: a stethoscope listens to heart
sounds, rate is one derived number from that, not the headline claim.
</commit_message>
<xml_diff>
--- a/presentation/Pulso_Pitch_Deck.pptx
+++ b/presentation/Pulso_Pitch_Deck.pptx
@@ -1304,7 +1304,7 @@
           <a:p>
             <a:r>
               <a:rPr lang="en-US" dirty="0"/>
-              <a:t>The regulatory line at the bottom is the one most teams won't have -- say it plainly, don't rush it.</a:t>
+              <a:t>Two channels, one product -- institutional gets us scale, direct gets us revenue while that closes.</a:t>
             </a:r>
             <a:endParaRPr lang="en-US" dirty="0"/>
           </a:p>
@@ -4411,7 +4411,7 @@
                 <a:ea typeface="Courier New" pitchFamily="34" charset="-122"/>
                 <a:cs typeface="Courier New" pitchFamily="34" charset="-120"/>
               </a:rPr>
-              <a:t>HEART RATE</a:t>
+              <a:t>RATE</a:t>
             </a:r>
             <a:endParaRPr lang="en-US" sz="1000" dirty="0"/>
           </a:p>
@@ -5760,7 +5760,7 @@
                 <a:ea typeface="Cambria" pitchFamily="34" charset="-122"/>
                 <a:cs typeface="Cambria" pitchFamily="34" charset="-120"/>
               </a:rPr>
-              <a:t>Sell hardware near cost.</a:t>
+              <a:t>Two buyers, two clocks.</a:t>
             </a:r>
             <a:endParaRPr lang="en-US" sz="3300" dirty="0"/>
           </a:p>
@@ -5777,7 +5777,7 @@
                 <a:ea typeface="Cambria" pitchFamily="34" charset="-122"/>
                 <a:cs typeface="Cambria" pitchFamily="34" charset="-120"/>
               </a:rPr>
-              <a:t>Charge the program, not the worker.</a:t>
+              <a:t>Hardware near cost either way.</a:t>
             </a:r>
             <a:endParaRPr lang="en-US" sz="3300" dirty="0"/>
           </a:p>
@@ -5841,7 +5841,7 @@
                 <a:ea typeface="Courier New" pitchFamily="34" charset="-122"/>
                 <a:cs typeface="Courier New" pitchFamily="34" charset="-120"/>
               </a:rPr>
-              <a:t>WHO PAYS</a:t>
+              <a:t>INSTITUTIONAL — B2B2G</a:t>
             </a:r>
             <a:endParaRPr lang="en-US" sz="1050" dirty="0"/>
           </a:p>
@@ -5883,7 +5883,7 @@
                 <a:ea typeface="Calibri" pitchFamily="34" charset="-122"/>
                 <a:cs typeface="Calibri" pitchFamily="34" charset="-120"/>
               </a:rPr>
-              <a:t>Not the health worker — they hold no budget. The buyer is the NGO or ministry that already funds and equips them.</a:t>
+              <a:t>NGOs and ministries that already fund community health workers. Scale channel — 3.8M workers, 98+ countries. Slow to close.</a:t>
             </a:r>
             <a:endParaRPr lang="en-US" sz="1350" dirty="0"/>
           </a:p>
@@ -5947,7 +5947,7 @@
                 <a:ea typeface="Courier New" pitchFamily="34" charset="-122"/>
                 <a:cs typeface="Courier New" pitchFamily="34" charset="-120"/>
               </a:rPr>
-              <a:t>HOW WE MAKE MONEY</a:t>
+              <a:t>DIRECT — B2B</a:t>
             </a:r>
             <a:endParaRPr lang="en-US" sz="1050" dirty="0"/>
           </a:p>
@@ -5989,7 +5989,7 @@
                 <a:ea typeface="Calibri" pitchFamily="34" charset="-122"/>
                 <a:cs typeface="Calibri" pitchFamily="34" charset="-120"/>
               </a:rPr>
-              <a:t>Hardware at near-cost, wide reach. A program-level reporting subscription, billed to the NGO or ministry.</a:t>
+              <a:t>Clinics and pharmacies with their own budget, no institution in between. Slower to scale, but closes today.</a:t>
             </a:r>
             <a:endParaRPr lang="en-US" sz="1350" dirty="0"/>
           </a:p>
@@ -6031,7 +6031,7 @@
                 <a:ea typeface="Cambria" pitchFamily="34" charset="-122"/>
                 <a:cs typeface="Cambria" pitchFamily="34" charset="-120"/>
               </a:rPr>
-              <a:t>3.8M community health workers, 98+ countries (WHO) — staying “not a medical device” is what lets us reach them now, not in three years.</a:t>
+              <a:t>Hardware near cost on both channels. A reporting subscription — billed per-program for institutions, per-clinic for direct buyers — is where margin comes from.</a:t>
             </a:r>
             <a:endParaRPr lang="en-US" sz="1550" dirty="0"/>
           </a:p>
@@ -6307,7 +6307,7 @@
                 <a:ea typeface="Courier New" pitchFamily="34" charset="-122"/>
                 <a:cs typeface="Courier New" pitchFamily="34" charset="-120"/>
               </a:rPr>
-              <a:t>PILOT</a:t>
+              <a:t>CLINIC DIRECT</a:t>
             </a:r>
             <a:endParaRPr lang="en-US" sz="1150" dirty="0"/>
           </a:p>
@@ -6346,7 +6346,7 @@
                 <a:ea typeface="Cambria" pitchFamily="34" charset="-122"/>
                 <a:cs typeface="Cambria" pitchFamily="34" charset="-120"/>
               </a:rPr>
-              <a:t>~$45–60</a:t>
+              <a:t>$149–199</a:t>
             </a:r>
             <a:endParaRPr lang="en-US" sz="2600" dirty="0"/>
           </a:p>
@@ -6385,7 +6385,7 @@
                 <a:ea typeface="Calibri" pitchFamily="34" charset="-122"/>
                 <a:cs typeface="Calibri" pitchFamily="34" charset="-120"/>
               </a:rPr>
-              <a:t>per kit, near cost</a:t>
+              <a:t>per kit + $15/mo software</a:t>
             </a:r>
             <a:endParaRPr lang="en-US" sz="1050" dirty="0"/>
           </a:p>
@@ -6431,7 +6431,7 @@
                 <a:ea typeface="Calibri" pitchFamily="34" charset="-122"/>
                 <a:cs typeface="Calibri" pitchFamily="34" charset="-120"/>
               </a:rPr>
-              <a:t>One hardware kit</a:t>
+              <a:t>Buy today, no institution needed</a:t>
             </a:r>
             <a:endParaRPr lang="en-US" sz="1150" dirty="0"/>
           </a:p>
@@ -6455,7 +6455,7 @@
                 <a:ea typeface="Calibri" pitchFamily="34" charset="-122"/>
                 <a:cs typeface="Calibri" pitchFamily="34" charset="-120"/>
               </a:rPr>
-              <a:t>For one health post to try it</a:t>
+              <a:t>One kit + clinic-facing app</a:t>
             </a:r>
             <a:endParaRPr lang="en-US" sz="1150" dirty="0"/>
           </a:p>

</xml_diff>